<commit_message>
Switch project to no-GPS demo mode for presentation readiness.
Log pothole detection events without location requirements, trigger immediate alerts, and align report/slides with camera+inference scope.

Made-with: Cursor
</commit_message>
<xml_diff>
--- a/Pothole_Detection_Presentation.pptx
+++ b/Pothole_Detection_Presentation.pptx
@@ -3225,7 +3225,7 @@
               <a:defRPr sz="2400"/>
             </a:pPr>
             <a:r>
-              <a:t>Goal: build a practical in-vehicle detector using camera + GPS + local alerts.</a:t>
+              <a:t>Goal: build a practical in-vehicle detector using camera + local alerts.</a:t>
             </a:r>
           </a:p>
         </p:txBody>
@@ -3296,7 +3296,7 @@
               <a:defRPr sz="2400"/>
             </a:pPr>
             <a:r>
-              <a:t>Store pothole locations only when confidence is high.</a:t>
+              <a:t>Store pothole detection events only when confidence is high.</a:t>
             </a:r>
           </a:p>
           <a:p>
@@ -3312,7 +3312,7 @@
               <a:defRPr sz="2400"/>
             </a:pPr>
             <a:r>
-              <a:t>Warn drivers when approaching known potholes in real time.</a:t>
+              <a:t>Notify immediately when potholes are detected in real time.</a:t>
             </a:r>
           </a:p>
         </p:txBody>
@@ -3391,7 +3391,7 @@
               <a:defRPr sz="2400"/>
             </a:pPr>
             <a:r>
-              <a:t>If predicted pothole: read NEO-6M GPS fix and store in SQLite.</a:t>
+              <a:t>If predicted pothole: log event details in SQLite.</a:t>
             </a:r>
           </a:p>
           <a:p>
@@ -3399,7 +3399,7 @@
               <a:defRPr sz="2400"/>
             </a:pPr>
             <a:r>
-              <a:t>Continuously compute distance to nearest stored pothole for alerts.</a:t>
+              <a:t>Trigger immediate alert and keep GPS extension as future work.</a:t>
             </a:r>
           </a:p>
         </p:txBody>
@@ -3462,7 +3462,7 @@
               <a:defRPr sz="2400"/>
             </a:pPr>
             <a:r>
-              <a:t>Hardware: Raspberry Pi 5 + Arducam 5MP + u-blox NEO-6M (UART).</a:t>
+              <a:t>Hardware: Raspberry Pi 5 + Arducam 5MP camera.</a:t>
             </a:r>
           </a:p>
           <a:p>
@@ -3470,7 +3470,7 @@
               <a:defRPr sz="2400"/>
             </a:pPr>
             <a:r>
-              <a:t>Software: Python, Ultralytics YOLO, OpenCV, gpsd-py3, SQLite.</a:t>
+              <a:t>Software: Python, Ultralytics YOLO, OpenCV, SQLite.</a:t>
             </a:r>
           </a:p>
           <a:p>
@@ -3478,7 +3478,7 @@
               <a:defRPr sz="2400"/>
             </a:pPr>
             <a:r>
-              <a:t>Services: capture, inference, GPS, database, proximity, notifier.</a:t>
+              <a:t>Services: capture, inference, database, notifier.</a:t>
             </a:r>
           </a:p>
           <a:p>
@@ -3486,7 +3486,7 @@
               <a:defRPr sz="2400"/>
             </a:pPr>
             <a:r>
-              <a:t>Main loop coordinates capture -&gt; classify -&gt; geotag -&gt; dedup -&gt; alert.</a:t>
+              <a:t>Main loop coordinates capture -&gt; classify -&gt; log event -&gt; alert.</a:t>
             </a:r>
           </a:p>
         </p:txBody>
@@ -3566,57 +3566,44 @@
             </a:r>
             <a:br/>
             <a:r>
-              <a:t>fix = gps.get_fix()</a:t>
-            </a:r>
-            <a:br/>
-            <a:r>
               <a:t>prediction = infer.predict(image_path)</a:t>
             </a:r>
             <a:br/>
             <a:br/>
             <a:r>
-              <a:t>if prediction["is_pothole"] and fix is not None:</a:t>
+              <a:t>if prediction["is_pothole"]:</a:t>
             </a:r>
             <a:br/>
             <a:r>
-              <a:t>    db.insert_pothole(</a:t>
+              <a:t>    db.insert_detection_event(</a:t>
             </a:r>
             <a:br/>
             <a:r>
-              <a:t>        latitude=fix.latitude,</a:t>
+              <a:t>        detected_at=datetime.now(tz=timezone.utc).isoformat(),</a:t>
             </a:r>
             <a:br/>
             <a:r>
-              <a:t>        longitude=fix.longitude,</a:t>
+              <a:t>        confidence=float(prediction["confidence"]),</a:t>
             </a:r>
             <a:br/>
             <a:r>
-              <a:t>        detected_at=fix.timestamp,</a:t>
+              <a:t>        image_id_optional=image_path.name,</a:t>
             </a:r>
             <a:br/>
             <a:r>
-              <a:t>        confidence=float(prediction["confidence"]),</a:t>
+              <a:t>    )</a:t>
             </a:r>
             <a:br/>
             <a:r>
-              <a:t>        image_id_optional=image_path.name,</a:t>
+              <a:t>    notifier.notify(</a:t>
             </a:r>
             <a:br/>
             <a:r>
+              <a:t>        f"Pothole detected (confidence={float(prediction['confidence']):.2f})"</a:t>
+            </a:r>
+            <a:br/>
+            <a:r>
               <a:t>    )</a:t>
-            </a:r>
-            <a:br/>
-            <a:br/>
-            <a:r>
-              <a:t>nearest = db.nearest_distance_m(fix.latitude, fix.longitude) if fix else None</a:t>
-            </a:r>
-            <a:br/>
-            <a:r>
-              <a:t>if proximity.should_alert(nearest):</a:t>
-            </a:r>
-            <a:br/>
-            <a:r>
-              <a:t>    notifier.notify(f"Pothole ahead in {nearest:.1f} meters.")</a:t>
             </a:r>
             <a:br/>
           </a:p>
@@ -3680,7 +3667,7 @@
               <a:defRPr sz="2400"/>
             </a:pPr>
             <a:r>
-              <a:t>Measured metrics: avg inference latency, frames/min, GPS fix usage, potholes saved.</a:t>
+              <a:t>Measured metrics: avg inference latency, frames/min, positive events saved.</a:t>
             </a:r>
           </a:p>
           <a:p>
@@ -3696,7 +3683,7 @@
               <a:defRPr sz="2400"/>
             </a:pPr>
             <a:r>
-              <a:t>Dedup distance reduces repeated inserts for the same pothole pass.</a:t>
+              <a:t>Detector remained stable in repeated runs on Raspberry Pi 5.</a:t>
             </a:r>
           </a:p>
           <a:p>
@@ -3704,7 +3691,7 @@
               <a:defRPr sz="2400"/>
             </a:pPr>
             <a:r>
-              <a:t>Next step: collect route-based precision/recall from field trials.</a:t>
+              <a:t>Next step: add GPS geotagging and route-based precision/recall.</a:t>
             </a:r>
           </a:p>
         </p:txBody>
@@ -3783,7 +3770,7 @@
               <a:defRPr sz="2400"/>
             </a:pPr>
             <a:r>
-              <a:t>Show: proximity alerts triggering near known pothole coordinates.</a:t>
+              <a:t>Show: immediate alerts triggering for detected potholes.</a:t>
             </a:r>
           </a:p>
           <a:p>
@@ -3870,7 +3857,7 @@
               <a:defRPr sz="2400"/>
             </a:pPr>
             <a:r>
-              <a:t>gpsd project: https://gpsd.io/</a:t>
+              <a:t>python-pptx project: https://python-pptx.readthedocs.io</a:t>
             </a:r>
           </a:p>
           <a:p>
@@ -3878,7 +3865,7 @@
               <a:defRPr sz="2400"/>
             </a:pPr>
             <a:r>
-              <a:t>u-blox NEO-6M product documentation and integration guides.</a:t>
+              <a:t>Future extension: u-blox NEO-6M integration guides.</a:t>
             </a:r>
           </a:p>
         </p:txBody>

</xml_diff>

<commit_message>
Restore GPS-enabled runtime, report, and presentation content.
Revert the no-GPS demo adjustments so detections are geotagged and proximity alerts depend on live GPS fixes.

Made-with: Cursor
</commit_message>
<xml_diff>
--- a/Pothole_Detection_Presentation.pptx
+++ b/Pothole_Detection_Presentation.pptx
@@ -3225,7 +3225,7 @@
               <a:defRPr sz="2400"/>
             </a:pPr>
             <a:r>
-              <a:t>Goal: build a practical in-vehicle detector using camera + local alerts.</a:t>
+              <a:t>Goal: build a practical in-vehicle detector using camera + GPS + local alerts.</a:t>
             </a:r>
           </a:p>
         </p:txBody>
@@ -3296,7 +3296,7 @@
               <a:defRPr sz="2400"/>
             </a:pPr>
             <a:r>
-              <a:t>Store pothole detection events only when confidence is high.</a:t>
+              <a:t>Store pothole locations only when confidence is high.</a:t>
             </a:r>
           </a:p>
           <a:p>
@@ -3312,7 +3312,7 @@
               <a:defRPr sz="2400"/>
             </a:pPr>
             <a:r>
-              <a:t>Notify immediately when potholes are detected in real time.</a:t>
+              <a:t>Warn drivers when approaching known potholes in real time.</a:t>
             </a:r>
           </a:p>
         </p:txBody>
@@ -3391,7 +3391,7 @@
               <a:defRPr sz="2400"/>
             </a:pPr>
             <a:r>
-              <a:t>If predicted pothole: log event details in SQLite.</a:t>
+              <a:t>If predicted pothole: read NEO-6M GPS fix and store in SQLite.</a:t>
             </a:r>
           </a:p>
           <a:p>
@@ -3399,7 +3399,7 @@
               <a:defRPr sz="2400"/>
             </a:pPr>
             <a:r>
-              <a:t>Trigger immediate alert and keep GPS extension as future work.</a:t>
+              <a:t>Continuously compute distance to nearest stored pothole for alerts.</a:t>
             </a:r>
           </a:p>
         </p:txBody>
@@ -3462,7 +3462,7 @@
               <a:defRPr sz="2400"/>
             </a:pPr>
             <a:r>
-              <a:t>Hardware: Raspberry Pi 5 + Arducam 5MP camera.</a:t>
+              <a:t>Hardware: Raspberry Pi 5 + Arducam 5MP + u-blox NEO-6M (UART).</a:t>
             </a:r>
           </a:p>
           <a:p>
@@ -3470,7 +3470,7 @@
               <a:defRPr sz="2400"/>
             </a:pPr>
             <a:r>
-              <a:t>Software: Python, Ultralytics YOLO, OpenCV, SQLite.</a:t>
+              <a:t>Software: Python, Ultralytics YOLO, OpenCV, gpsd-py3, SQLite.</a:t>
             </a:r>
           </a:p>
           <a:p>
@@ -3478,7 +3478,7 @@
               <a:defRPr sz="2400"/>
             </a:pPr>
             <a:r>
-              <a:t>Services: capture, inference, database, notifier.</a:t>
+              <a:t>Services: capture, inference, GPS, database, proximity, notifier.</a:t>
             </a:r>
           </a:p>
           <a:p>
@@ -3486,7 +3486,7 @@
               <a:defRPr sz="2400"/>
             </a:pPr>
             <a:r>
-              <a:t>Main loop coordinates capture -&gt; classify -&gt; log event -&gt; alert.</a:t>
+              <a:t>Main loop coordinates capture -&gt; classify -&gt; geotag -&gt; dedup -&gt; alert.</a:t>
             </a:r>
           </a:p>
         </p:txBody>
@@ -3566,23 +3566,35 @@
             </a:r>
             <a:br/>
             <a:r>
+              <a:t>fix = gps.get_fix()</a:t>
+            </a:r>
+            <a:br/>
+            <a:r>
               <a:t>prediction = infer.predict(image_path)</a:t>
             </a:r>
             <a:br/>
             <a:br/>
             <a:r>
-              <a:t>if prediction["is_pothole"]:</a:t>
+              <a:t>if prediction["is_pothole"] and fix is not None:</a:t>
             </a:r>
             <a:br/>
             <a:r>
-              <a:t>    db.insert_detection_event(</a:t>
+              <a:t>    db.insert_pothole(</a:t>
             </a:r>
             <a:br/>
             <a:r>
-              <a:t>        detected_at=datetime.now(tz=timezone.utc).isoformat(),</a:t>
+              <a:t>        latitude=fix.latitude,</a:t>
             </a:r>
             <a:br/>
             <a:r>
+              <a:t>        longitude=fix.longitude,</a:t>
+            </a:r>
+            <a:br/>
+            <a:r>
+              <a:t>        detected_at=fix.timestamp,</a:t>
+            </a:r>
+            <a:br/>
+            <a:r>
               <a:t>        confidence=float(prediction["confidence"]),</a:t>
             </a:r>
             <a:br/>
@@ -3594,16 +3606,17 @@
               <a:t>    )</a:t>
             </a:r>
             <a:br/>
-            <a:r>
-              <a:t>    notifier.notify(</a:t>
-            </a:r>
             <a:br/>
             <a:r>
-              <a:t>        f"Pothole detected (confidence={float(prediction['confidence']):.2f})"</a:t>
+              <a:t>nearest = db.nearest_distance_m(fix.latitude, fix.longitude) if fix else None</a:t>
             </a:r>
             <a:br/>
             <a:r>
-              <a:t>    )</a:t>
+              <a:t>if proximity.should_alert(nearest):</a:t>
+            </a:r>
+            <a:br/>
+            <a:r>
+              <a:t>    notifier.notify(f"Pothole ahead in {nearest:.1f} meters.")</a:t>
             </a:r>
             <a:br/>
           </a:p>
@@ -3667,7 +3680,7 @@
               <a:defRPr sz="2400"/>
             </a:pPr>
             <a:r>
-              <a:t>Measured metrics: avg inference latency, frames/min, positive events saved.</a:t>
+              <a:t>Measured metrics: avg inference latency, frames/min, GPS fix usage, potholes saved.</a:t>
             </a:r>
           </a:p>
           <a:p>
@@ -3683,7 +3696,7 @@
               <a:defRPr sz="2400"/>
             </a:pPr>
             <a:r>
-              <a:t>Detector remained stable in repeated runs on Raspberry Pi 5.</a:t>
+              <a:t>Dedup distance reduces repeated inserts for the same pothole pass.</a:t>
             </a:r>
           </a:p>
           <a:p>
@@ -3691,7 +3704,7 @@
               <a:defRPr sz="2400"/>
             </a:pPr>
             <a:r>
-              <a:t>Next step: add GPS geotagging and route-based precision/recall.</a:t>
+              <a:t>Next step: collect route-based precision/recall from field trials.</a:t>
             </a:r>
           </a:p>
         </p:txBody>
@@ -3770,7 +3783,7 @@
               <a:defRPr sz="2400"/>
             </a:pPr>
             <a:r>
-              <a:t>Show: immediate alerts triggering for detected potholes.</a:t>
+              <a:t>Show: proximity alerts triggering near known pothole coordinates.</a:t>
             </a:r>
           </a:p>
           <a:p>
@@ -3857,7 +3870,7 @@
               <a:defRPr sz="2400"/>
             </a:pPr>
             <a:r>
-              <a:t>python-pptx project: https://python-pptx.readthedocs.io</a:t>
+              <a:t>gpsd project: https://gpsd.io/</a:t>
             </a:r>
           </a:p>
           <a:p>
@@ -3865,7 +3878,7 @@
               <a:defRPr sz="2400"/>
             </a:pPr>
             <a:r>
-              <a:t>Future extension: u-blox NEO-6M integration guides.</a:t>
+              <a:t>u-blox NEO-6M product documentation and integration guides.</a:t>
             </a:r>
           </a:p>
         </p:txBody>

</xml_diff>